<commit_message>
Selection of the integration method and updating of the thrust calculation.
- Runge-Kutta 4 has been implemented with the possibility of choosing Euler instead
- trust is now Calculated from seaLevelThrust and vacuumThrust, which are set in the rocket configuration
</commit_message>
<xml_diff>
--- a/docs/ThrustVsExhaustVelocityAnalysis.pptx
+++ b/docs/ThrustVsExhaustVelocityAnalysis.pptx
@@ -250,7 +250,7 @@
           <a:p>
             <a:fld id="{9412F206-934A-4AEB-8CDD-488D750A95A8}" type="datetimeFigureOut">
               <a:rPr lang="ru-RU" smtClean="0"/>
-              <a:t>29.03.2026</a:t>
+              <a:t>30.03.2026</a:t>
             </a:fld>
             <a:endParaRPr lang="ru-RU"/>
           </a:p>
@@ -420,7 +420,7 @@
           <a:p>
             <a:fld id="{9412F206-934A-4AEB-8CDD-488D750A95A8}" type="datetimeFigureOut">
               <a:rPr lang="ru-RU" smtClean="0"/>
-              <a:t>29.03.2026</a:t>
+              <a:t>30.03.2026</a:t>
             </a:fld>
             <a:endParaRPr lang="ru-RU"/>
           </a:p>
@@ -600,7 +600,7 @@
           <a:p>
             <a:fld id="{9412F206-934A-4AEB-8CDD-488D750A95A8}" type="datetimeFigureOut">
               <a:rPr lang="ru-RU" smtClean="0"/>
-              <a:t>29.03.2026</a:t>
+              <a:t>30.03.2026</a:t>
             </a:fld>
             <a:endParaRPr lang="ru-RU"/>
           </a:p>
@@ -770,7 +770,7 @@
           <a:p>
             <a:fld id="{9412F206-934A-4AEB-8CDD-488D750A95A8}" type="datetimeFigureOut">
               <a:rPr lang="ru-RU" smtClean="0"/>
-              <a:t>29.03.2026</a:t>
+              <a:t>30.03.2026</a:t>
             </a:fld>
             <a:endParaRPr lang="ru-RU"/>
           </a:p>
@@ -1014,7 +1014,7 @@
           <a:p>
             <a:fld id="{9412F206-934A-4AEB-8CDD-488D750A95A8}" type="datetimeFigureOut">
               <a:rPr lang="ru-RU" smtClean="0"/>
-              <a:t>29.03.2026</a:t>
+              <a:t>30.03.2026</a:t>
             </a:fld>
             <a:endParaRPr lang="ru-RU"/>
           </a:p>
@@ -1246,7 +1246,7 @@
           <a:p>
             <a:fld id="{9412F206-934A-4AEB-8CDD-488D750A95A8}" type="datetimeFigureOut">
               <a:rPr lang="ru-RU" smtClean="0"/>
-              <a:t>29.03.2026</a:t>
+              <a:t>30.03.2026</a:t>
             </a:fld>
             <a:endParaRPr lang="ru-RU"/>
           </a:p>
@@ -1613,7 +1613,7 @@
           <a:p>
             <a:fld id="{9412F206-934A-4AEB-8CDD-488D750A95A8}" type="datetimeFigureOut">
               <a:rPr lang="ru-RU" smtClean="0"/>
-              <a:t>29.03.2026</a:t>
+              <a:t>30.03.2026</a:t>
             </a:fld>
             <a:endParaRPr lang="ru-RU"/>
           </a:p>
@@ -1731,7 +1731,7 @@
           <a:p>
             <a:fld id="{9412F206-934A-4AEB-8CDD-488D750A95A8}" type="datetimeFigureOut">
               <a:rPr lang="ru-RU" smtClean="0"/>
-              <a:t>29.03.2026</a:t>
+              <a:t>30.03.2026</a:t>
             </a:fld>
             <a:endParaRPr lang="ru-RU"/>
           </a:p>
@@ -1826,7 +1826,7 @@
           <a:p>
             <a:fld id="{9412F206-934A-4AEB-8CDD-488D750A95A8}" type="datetimeFigureOut">
               <a:rPr lang="ru-RU" smtClean="0"/>
-              <a:t>29.03.2026</a:t>
+              <a:t>30.03.2026</a:t>
             </a:fld>
             <a:endParaRPr lang="ru-RU"/>
           </a:p>
@@ -2103,7 +2103,7 @@
           <a:p>
             <a:fld id="{9412F206-934A-4AEB-8CDD-488D750A95A8}" type="datetimeFigureOut">
               <a:rPr lang="ru-RU" smtClean="0"/>
-              <a:t>29.03.2026</a:t>
+              <a:t>30.03.2026</a:t>
             </a:fld>
             <a:endParaRPr lang="ru-RU"/>
           </a:p>
@@ -2360,7 +2360,7 @@
           <a:p>
             <a:fld id="{9412F206-934A-4AEB-8CDD-488D750A95A8}" type="datetimeFigureOut">
               <a:rPr lang="ru-RU" smtClean="0"/>
-              <a:t>29.03.2026</a:t>
+              <a:t>30.03.2026</a:t>
             </a:fld>
             <a:endParaRPr lang="ru-RU"/>
           </a:p>
@@ -2573,7 +2573,7 @@
           <a:p>
             <a:fld id="{9412F206-934A-4AEB-8CDD-488D750A95A8}" type="datetimeFigureOut">
               <a:rPr lang="ru-RU" smtClean="0"/>
-              <a:t>29.03.2026</a:t>
+              <a:t>30.03.2026</a:t>
             </a:fld>
             <a:endParaRPr lang="ru-RU"/>
           </a:p>
@@ -3927,8 +3927,8 @@
           <a:chExt cx="0" cy="0"/>
         </a:xfrm>
       </p:grpSpPr>
-      <mc:AlternateContent xmlns:mc="http://schemas.openxmlformats.org/markup-compatibility/2006">
-        <mc:Choice xmlns:a14="http://schemas.microsoft.com/office/drawing/2010/main" Requires="a14">
+      <mc:AlternateContent xmlns:mc="http://schemas.openxmlformats.org/markup-compatibility/2006" xmlns:a14="http://schemas.microsoft.com/office/drawing/2010/main">
+        <mc:Choice Requires="a14">
           <p:sp>
             <p:nvSpPr>
               <p:cNvPr id="3" name="Объект 2">
@@ -4428,7 +4428,7 @@
             </p:txBody>
           </p:sp>
         </mc:Choice>
-        <mc:Fallback>
+        <mc:Fallback xmlns="">
           <p:sp>
             <p:nvSpPr>
               <p:cNvPr id="3" name="Объект 2">
@@ -4480,8 +4480,8 @@
           </p:sp>
         </mc:Fallback>
       </mc:AlternateContent>
-      <mc:AlternateContent xmlns:mc="http://schemas.openxmlformats.org/markup-compatibility/2006">
-        <mc:Choice xmlns:a14="http://schemas.microsoft.com/office/drawing/2010/main" Requires="a14">
+      <mc:AlternateContent xmlns:mc="http://schemas.openxmlformats.org/markup-compatibility/2006" xmlns:a14="http://schemas.microsoft.com/office/drawing/2010/main">
+        <mc:Choice Requires="a14">
           <p:sp>
             <p:nvSpPr>
               <p:cNvPr id="5" name="TextBox 4">
@@ -5019,7 +5019,7 @@
             </p:txBody>
           </p:sp>
         </mc:Choice>
-        <mc:Fallback>
+        <mc:Fallback xmlns="">
           <p:sp>
             <p:nvSpPr>
               <p:cNvPr id="5" name="TextBox 4">
@@ -5072,8 +5072,8 @@
           </p:sp>
         </mc:Fallback>
       </mc:AlternateContent>
-      <mc:AlternateContent xmlns:mc="http://schemas.openxmlformats.org/markup-compatibility/2006">
-        <mc:Choice xmlns:a14="http://schemas.microsoft.com/office/drawing/2010/main" Requires="a14">
+      <mc:AlternateContent xmlns:mc="http://schemas.openxmlformats.org/markup-compatibility/2006" xmlns:a14="http://schemas.microsoft.com/office/drawing/2010/main">
+        <mc:Choice Requires="a14">
           <p:sp>
             <p:nvSpPr>
               <p:cNvPr id="7" name="TextBox 6">
@@ -5386,7 +5386,7 @@
             </p:txBody>
           </p:sp>
         </mc:Choice>
-        <mc:Fallback>
+        <mc:Fallback xmlns="">
           <p:sp>
             <p:nvSpPr>
               <p:cNvPr id="7" name="TextBox 6">
@@ -5439,8 +5439,8 @@
           </p:sp>
         </mc:Fallback>
       </mc:AlternateContent>
-      <mc:AlternateContent xmlns:mc="http://schemas.openxmlformats.org/markup-compatibility/2006">
-        <mc:Choice xmlns:a14="http://schemas.microsoft.com/office/drawing/2010/main" Requires="a14">
+      <mc:AlternateContent xmlns:mc="http://schemas.openxmlformats.org/markup-compatibility/2006" xmlns:a14="http://schemas.microsoft.com/office/drawing/2010/main">
+        <mc:Choice Requires="a14">
           <p:sp>
             <p:nvSpPr>
               <p:cNvPr id="9" name="TextBox 8">
@@ -6066,7 +6066,7 @@
             </p:txBody>
           </p:sp>
         </mc:Choice>
-        <mc:Fallback>
+        <mc:Fallback xmlns="">
           <p:sp>
             <p:nvSpPr>
               <p:cNvPr id="9" name="TextBox 8">
@@ -6119,8 +6119,8 @@
           </p:sp>
         </mc:Fallback>
       </mc:AlternateContent>
-      <mc:AlternateContent xmlns:mc="http://schemas.openxmlformats.org/markup-compatibility/2006">
-        <mc:Choice xmlns:a14="http://schemas.microsoft.com/office/drawing/2010/main" Requires="a14">
+      <mc:AlternateContent xmlns:mc="http://schemas.openxmlformats.org/markup-compatibility/2006" xmlns:a14="http://schemas.microsoft.com/office/drawing/2010/main">
+        <mc:Choice Requires="a14">
           <p:sp>
             <p:nvSpPr>
               <p:cNvPr id="12" name="TextBox 11">
@@ -6633,7 +6633,7 @@
             </p:txBody>
           </p:sp>
         </mc:Choice>
-        <mc:Fallback>
+        <mc:Fallback xmlns="">
           <p:sp>
             <p:nvSpPr>
               <p:cNvPr id="12" name="TextBox 11">
@@ -6716,8 +6716,8 @@
           <a:chExt cx="0" cy="0"/>
         </a:xfrm>
       </p:grpSpPr>
-      <mc:AlternateContent xmlns:mc="http://schemas.openxmlformats.org/markup-compatibility/2006">
-        <mc:Choice xmlns:a14="http://schemas.microsoft.com/office/drawing/2010/main" Requires="a14">
+      <mc:AlternateContent xmlns:mc="http://schemas.openxmlformats.org/markup-compatibility/2006" xmlns:a14="http://schemas.microsoft.com/office/drawing/2010/main">
+        <mc:Choice Requires="a14">
           <p:sp>
             <p:nvSpPr>
               <p:cNvPr id="8" name="TextBox 7">
@@ -7341,7 +7341,7 @@
             </p:txBody>
           </p:sp>
         </mc:Choice>
-        <mc:Fallback>
+        <mc:Fallback xmlns="">
           <p:sp>
             <p:nvSpPr>
               <p:cNvPr id="8" name="TextBox 7">
@@ -7394,8 +7394,8 @@
           </p:sp>
         </mc:Fallback>
       </mc:AlternateContent>
-      <mc:AlternateContent xmlns:mc="http://schemas.openxmlformats.org/markup-compatibility/2006">
-        <mc:Choice xmlns:a14="http://schemas.microsoft.com/office/drawing/2010/main" Requires="a14">
+      <mc:AlternateContent xmlns:mc="http://schemas.openxmlformats.org/markup-compatibility/2006" xmlns:a14="http://schemas.microsoft.com/office/drawing/2010/main">
+        <mc:Choice Requires="a14">
           <p:sp>
             <p:nvSpPr>
               <p:cNvPr id="13" name="TextBox 12">
@@ -7964,7 +7964,7 @@
             </p:txBody>
           </p:sp>
         </mc:Choice>
-        <mc:Fallback>
+        <mc:Fallback xmlns="">
           <p:sp>
             <p:nvSpPr>
               <p:cNvPr id="13" name="TextBox 12">
@@ -8017,8 +8017,8 @@
           </p:sp>
         </mc:Fallback>
       </mc:AlternateContent>
-      <mc:AlternateContent xmlns:mc="http://schemas.openxmlformats.org/markup-compatibility/2006">
-        <mc:Choice xmlns:a14="http://schemas.microsoft.com/office/drawing/2010/main" Requires="a14">
+      <mc:AlternateContent xmlns:mc="http://schemas.openxmlformats.org/markup-compatibility/2006" xmlns:a14="http://schemas.microsoft.com/office/drawing/2010/main">
+        <mc:Choice Requires="a14">
           <p:sp>
             <p:nvSpPr>
               <p:cNvPr id="15" name="TextBox 14">
@@ -8624,7 +8624,7 @@
             </p:txBody>
           </p:sp>
         </mc:Choice>
-        <mc:Fallback>
+        <mc:Fallback xmlns="">
           <p:sp>
             <p:nvSpPr>
               <p:cNvPr id="15" name="TextBox 14">
@@ -8677,8 +8677,8 @@
           </p:sp>
         </mc:Fallback>
       </mc:AlternateContent>
-      <mc:AlternateContent xmlns:mc="http://schemas.openxmlformats.org/markup-compatibility/2006">
-        <mc:Choice xmlns:a14="http://schemas.microsoft.com/office/drawing/2010/main" Requires="a14">
+      <mc:AlternateContent xmlns:mc="http://schemas.openxmlformats.org/markup-compatibility/2006" xmlns:a14="http://schemas.microsoft.com/office/drawing/2010/main">
+        <mc:Choice Requires="a14">
           <p:sp>
             <p:nvSpPr>
               <p:cNvPr id="17" name="TextBox 16">
@@ -9333,7 +9333,7 @@
             </p:txBody>
           </p:sp>
         </mc:Choice>
-        <mc:Fallback>
+        <mc:Fallback xmlns="">
           <p:sp>
             <p:nvSpPr>
               <p:cNvPr id="17" name="TextBox 16">
@@ -9843,7 +9843,7 @@
             <p:ph idx="1"/>
           </p:nvPr>
         </p:nvPicPr>
-        <p:blipFill>
+        <p:blipFill rotWithShape="1">
           <a:blip r:embed="rId2">
             <a:extLst>
               <a:ext uri="{28A0092B-C50C-407E-A947-70E740481C1C}">
@@ -9851,14 +9851,13 @@
               </a:ext>
             </a:extLst>
           </a:blip>
-          <a:stretch>
-            <a:fillRect/>
-          </a:stretch>
+          <a:srcRect t="14640" b="14640"/>
+          <a:stretch/>
         </p:blipFill>
         <p:spPr>
           <a:xfrm>
-            <a:off x="-1" y="-1565276"/>
-            <a:ext cx="10691813" cy="10691813"/>
+            <a:off x="0" y="0"/>
+            <a:ext cx="10691812" cy="7561263"/>
           </a:xfrm>
         </p:spPr>
       </p:pic>

</xml_diff>